<commit_message>
Full-text pass on the 37 papers the novelty claim and paper rely on
Adds read_depth to all 227 entries (35 full), full-text check sections,
NOVELTY 5.8 revised matrix, paper and deck corrections.

Co-Authored-By: Claude Opus 5.5 <noreply@anthropic.com>
Claude-Session: https://claude.ai/code/session_0193TRfxuA1i6oKL3GKBsouq
</commit_message>
<xml_diff>
--- a/deck/why/EvidEO-why-it-matters.pptx
+++ b/deck/why/EvidEO-why-it-matters.pptx
@@ -112,7 +112,7 @@
   <p:extLst>
     <p:ext uri="{521415D9-36F7-43E2-AB2F-B90AF26B5E84}">
       <p14:sectionLst xmlns:p14="http://schemas.microsoft.com/office/powerpoint/2010/main">
-        <p14:section name="Why EvidEO" id="{64f37105-d261-6cb9-84dd-52f1cd67fbe9}">
+        <p14:section name="Why EvidEO" id="{b35868b3-20e4-b8f9-8830-0f7890f64f02}">
           <p14:sldIdLst>
             <p14:sldId id="256"/>
             <p14:sldId id="257"/>
@@ -3068,7 +3068,7 @@
           <a:p>
             <a:r>
               <a:rPr lang="en-US" dirty="0"/>
-              <a:t>Why it matters: every ingredient exists somewhere, but no system in our 225-paper archive delivers more than two of these six together, and none tells a non-expert when not to trust an answer. The bottleneck we found is local labels and instrument quality, not bigger language models. Next: improve the instrument, gather Indian labels across events, run a small user study, and submit the paper.</a:t>
+              <a:t>Why it matters: every ingredient exists somewhere in partial form, but after reading the 37 closest papers in full, no research system delivers more than one of these six in full, and none tells a non-expert when not to trust an answer. The bottleneck we found is local labels and instrument quality, not bigger language models. Next: improve the instrument, gather Indian labels across events, run a small user study, and submit the paper.</a:t>
             </a:r>
             <a:endParaRPr lang="en-US" dirty="0"/>
           </a:p>
@@ -5008,7 +5008,7 @@
                 <a:ea typeface="Times New Roman" pitchFamily="34" charset="-122"/>
                 <a:cs typeface="Times New Roman" pitchFamily="34" charset="-120"/>
               </a:rPr>
-              <a:t>31 to 64%</a:t>
+              <a:t>32 to 64%</a:t>
             </a:r>
             <a:endParaRPr lang="en-US" sz="2400" dirty="0"/>
           </a:p>
@@ -7899,7 +7899,7 @@
                   <a:schemeClr val="tx1"/>
                 </a:solidFill>
               </a:rPr>
-              <a:t>NO SYSTEM IN 225 PAPERS HAS MORE THAN TWO OF THESE</a:t>
+              <a:t>READ IN FULL: NO OTHER SYSTEM HAS MORE THAN ONE</a:t>
             </a:r>
             <a:endParaRPr lang="en-US" sz="1400" dirty="0"/>
           </a:p>
@@ -7928,12 +7928,12 @@
             <a:tbl>
               <a:tblPr/>
               <a:tblGrid>
-                <a:gridCol w="1737360"/>
-                <a:gridCol w="621792"/>
-                <a:gridCol w="621792"/>
-                <a:gridCol w="658368"/>
-                <a:gridCol w="658368"/>
-                <a:gridCol w="548640"/>
+                <a:gridCol w="1691640"/>
+                <a:gridCol w="566928"/>
+                <a:gridCol w="676656"/>
+                <a:gridCol w="640080"/>
+                <a:gridCol w="566928"/>
+                <a:gridCol w="704088"/>
               </a:tblGrid>
               <a:tr h="329184">
                 <a:tc>
@@ -8002,7 +8002,7 @@
                         <a:buNone/>
                       </a:pPr>
                       <a:r>
-                        <a:rPr lang="en-US" sz="1000" b="1" dirty="0">
+                        <a:rPr lang="en-US" sz="900" b="1" dirty="0">
                           <a:solidFill>
                             <a:srgbClr val="1F5A99"/>
                           </a:solidFill>
@@ -8012,7 +8012,7 @@
                         </a:rPr>
                         <a:t>EvidEO</a:t>
                       </a:r>
-                      <a:endParaRPr lang="en-US" sz="1000" dirty="0">
+                      <a:endParaRPr lang="en-US" sz="900" dirty="0">
                         <a:latin typeface="Calibri" charset="0"/>
                         <a:ea typeface="Calibri" charset="0"/>
                         <a:cs typeface="Calibri" charset="0"/>
@@ -8070,7 +8070,7 @@
                         <a:buNone/>
                       </a:pPr>
                       <a:r>
-                        <a:rPr lang="en-US" sz="1000" b="1" dirty="0">
+                        <a:rPr lang="en-US" sz="900" b="1" dirty="0">
                           <a:solidFill>
                             <a:srgbClr val="1E2430"/>
                           </a:solidFill>
@@ -8078,9 +8078,9 @@
                           <a:ea typeface="Calibri" pitchFamily="34" charset="-122"/>
                           <a:cs typeface="Calibri" pitchFamily="34" charset="-120"/>
                         </a:rPr>
-                        <a:t>EO-Gym</a:t>
+                        <a:t>Copernicus GFM</a:t>
                       </a:r>
-                      <a:endParaRPr lang="en-US" sz="1000" dirty="0">
+                      <a:endParaRPr lang="en-US" sz="900" dirty="0">
                         <a:latin typeface="Calibri" charset="0"/>
                         <a:ea typeface="Calibri" charset="0"/>
                         <a:cs typeface="Calibri" charset="0"/>
@@ -8138,7 +8138,7 @@
                         <a:buNone/>
                       </a:pPr>
                       <a:r>
-                        <a:rPr lang="en-US" sz="1000" b="1" dirty="0">
+                        <a:rPr lang="en-US" sz="900" b="1" dirty="0">
                           <a:solidFill>
                             <a:srgbClr val="1E2430"/>
                           </a:solidFill>
@@ -8146,9 +8146,9 @@
                           <a:ea typeface="Calibri" pitchFamily="34" charset="-122"/>
                           <a:cs typeface="Calibri" pitchFamily="34" charset="-120"/>
                         </a:rPr>
-                        <a:t>NRSC maps</a:t>
+                        <a:t>RSure-Agent</a:t>
                       </a:r>
-                      <a:endParaRPr lang="en-US" sz="1000" dirty="0">
+                      <a:endParaRPr lang="en-US" sz="900" dirty="0">
                         <a:latin typeface="Calibri" charset="0"/>
                         <a:ea typeface="Calibri" charset="0"/>
                         <a:cs typeface="Calibri" charset="0"/>
@@ -8206,7 +8206,7 @@
                         <a:buNone/>
                       </a:pPr>
                       <a:r>
-                        <a:rPr lang="en-US" sz="1000" b="1" dirty="0">
+                        <a:rPr lang="en-US" sz="900" b="1" dirty="0">
                           <a:solidFill>
                             <a:srgbClr val="1E2430"/>
                           </a:solidFill>
@@ -8214,9 +8214,9 @@
                           <a:ea typeface="Calibri" pitchFamily="34" charset="-122"/>
                           <a:cs typeface="Calibri" pitchFamily="34" charset="-120"/>
                         </a:rPr>
-                        <a:t>SHRUG-FM</a:t>
+                        <a:t>EO-Gym</a:t>
                       </a:r>
-                      <a:endParaRPr lang="en-US" sz="1000" dirty="0">
+                      <a:endParaRPr lang="en-US" sz="900" dirty="0">
                         <a:latin typeface="Calibri" charset="0"/>
                         <a:ea typeface="Calibri" charset="0"/>
                         <a:cs typeface="Calibri" charset="0"/>
@@ -8274,7 +8274,7 @@
                         <a:buNone/>
                       </a:pPr>
                       <a:r>
-                        <a:rPr lang="en-US" sz="1000" b="1" dirty="0">
+                        <a:rPr lang="en-US" sz="900" b="1" dirty="0">
                           <a:solidFill>
                             <a:srgbClr val="1E2430"/>
                           </a:solidFill>
@@ -8282,9 +8282,9 @@
                           <a:ea typeface="Calibri" pitchFamily="34" charset="-122"/>
                           <a:cs typeface="Calibri" pitchFamily="34" charset="-120"/>
                         </a:rPr>
-                        <a:t>RS-VLMs</a:t>
+                        <a:t>Google Earth AI</a:t>
                       </a:r>
-                      <a:endParaRPr lang="en-US" sz="1000" dirty="0">
+                      <a:endParaRPr lang="en-US" sz="900" dirty="0">
                         <a:latin typeface="Calibri" charset="0"/>
                         <a:ea typeface="Calibri" charset="0"/>
                         <a:cs typeface="Calibri" charset="0"/>
@@ -8479,6 +8479,17 @@
                       <a:pPr algn="ctr" indent="0" marL="0">
                         <a:buNone/>
                       </a:pPr>
+                      <a:r>
+                        <a:rPr lang="en-US" sz="1200" dirty="0">
+                          <a:solidFill>
+                            <a:srgbClr val="1E2430"/>
+                          </a:solidFill>
+                          <a:latin typeface="Calibri" pitchFamily="34" charset="0"/>
+                          <a:ea typeface="Calibri" pitchFamily="34" charset="-122"/>
+                          <a:cs typeface="Calibri" pitchFamily="34" charset="-120"/>
+                        </a:rPr>
+                        <a:t>◐</a:t>
+                      </a:r>
                       <a:endParaRPr lang="en-US" sz="1200" dirty="0">
                         <a:latin typeface="Calibri" charset="0"/>
                         <a:ea typeface="Calibri" charset="0"/>
@@ -8593,17 +8604,6 @@
                       <a:pPr algn="ctr" indent="0" marL="0">
                         <a:buNone/>
                       </a:pPr>
-                      <a:r>
-                        <a:rPr lang="en-US" sz="1200" dirty="0">
-                          <a:solidFill>
-                            <a:srgbClr val="1E2430"/>
-                          </a:solidFill>
-                          <a:latin typeface="Calibri" pitchFamily="34" charset="0"/>
-                          <a:ea typeface="Calibri" pitchFamily="34" charset="-122"/>
-                          <a:cs typeface="Calibri" pitchFamily="34" charset="-120"/>
-                        </a:rPr>
-                        <a:t>◐</a:t>
-                      </a:r>
                       <a:endParaRPr lang="en-US" sz="1200" dirty="0">
                         <a:latin typeface="Calibri" charset="0"/>
                         <a:ea typeface="Calibri" charset="0"/>
@@ -8856,63 +8856,17 @@
                       <a:pPr algn="ctr" indent="0" marL="0">
                         <a:buNone/>
                       </a:pPr>
-                      <a:endParaRPr lang="en-US" sz="1200" dirty="0">
-                        <a:latin typeface="Calibri" charset="0"/>
-                        <a:ea typeface="Calibri" charset="0"/>
-                        <a:cs typeface="Calibri" charset="0"/>
-                      </a:endParaRPr>
-                    </a:p>
-                  </a:txBody>
-                  <a:tcPr marL="36576" marR="36576" marT="36576" marB="36576" anchor="ctr">
-                    <a:lnL w="9525" cap="flat" cmpd="sng" algn="ctr">
-                      <a:solidFill>
-                        <a:srgbClr val="C9D3E0"/>
-                      </a:solidFill>
-                      <a:prstDash val="solid"/>
-                      <a:round/>
-                      <a:headEnd type="none" w="med" len="med"/>
-                      <a:tailEnd type="none" w="med" len="med"/>
-                    </a:lnL>
-                    <a:lnR w="9525" cap="flat" cmpd="sng" algn="ctr">
-                      <a:solidFill>
-                        <a:srgbClr val="C9D3E0"/>
-                      </a:solidFill>
-                      <a:prstDash val="solid"/>
-                      <a:round/>
-                      <a:headEnd type="none" w="med" len="med"/>
-                      <a:tailEnd type="none" w="med" len="med"/>
-                    </a:lnR>
-                    <a:lnT w="9525" cap="flat" cmpd="sng" algn="ctr">
-                      <a:solidFill>
-                        <a:srgbClr val="C9D3E0"/>
-                      </a:solidFill>
-                      <a:prstDash val="solid"/>
-                      <a:round/>
-                      <a:headEnd type="none" w="med" len="med"/>
-                      <a:tailEnd type="none" w="med" len="med"/>
-                    </a:lnT>
-                    <a:lnB w="9525" cap="flat" cmpd="sng" algn="ctr">
-                      <a:solidFill>
-                        <a:srgbClr val="C9D3E0"/>
-                      </a:solidFill>
-                      <a:prstDash val="solid"/>
-                      <a:round/>
-                      <a:headEnd type="none" w="med" len="med"/>
-                      <a:tailEnd type="none" w="med" len="med"/>
-                    </a:lnB>
-                    <a:solidFill>
-                      <a:srgbClr val="FFFFFF"/>
-                    </a:solidFill>
-                  </a:tcPr>
-                </a:tc>
-                <a:tc>
-                  <a:txBody>
-                    <a:bodyPr/>
-                    <a:lstStyle/>
-                    <a:p>
-                      <a:pPr algn="ctr" indent="0" marL="0">
-                        <a:buNone/>
-                      </a:pPr>
+                      <a:r>
+                        <a:rPr lang="en-US" sz="1200" dirty="0">
+                          <a:solidFill>
+                            <a:srgbClr val="1E2430"/>
+                          </a:solidFill>
+                          <a:latin typeface="Calibri" pitchFamily="34" charset="0"/>
+                          <a:ea typeface="Calibri" pitchFamily="34" charset="-122"/>
+                          <a:cs typeface="Calibri" pitchFamily="34" charset="-120"/>
+                        </a:rPr>
+                        <a:t>◐</a:t>
+                      </a:r>
                       <a:endParaRPr lang="en-US" sz="1200" dirty="0">
                         <a:latin typeface="Calibri" charset="0"/>
                         <a:ea typeface="Calibri" charset="0"/>
@@ -8981,6 +8935,63 @@
                         </a:rPr>
                         <a:t>◐</a:t>
                       </a:r>
+                      <a:endParaRPr lang="en-US" sz="1200" dirty="0">
+                        <a:latin typeface="Calibri" charset="0"/>
+                        <a:ea typeface="Calibri" charset="0"/>
+                        <a:cs typeface="Calibri" charset="0"/>
+                      </a:endParaRPr>
+                    </a:p>
+                  </a:txBody>
+                  <a:tcPr marL="36576" marR="36576" marT="36576" marB="36576" anchor="ctr">
+                    <a:lnL w="9525" cap="flat" cmpd="sng" algn="ctr">
+                      <a:solidFill>
+                        <a:srgbClr val="C9D3E0"/>
+                      </a:solidFill>
+                      <a:prstDash val="solid"/>
+                      <a:round/>
+                      <a:headEnd type="none" w="med" len="med"/>
+                      <a:tailEnd type="none" w="med" len="med"/>
+                    </a:lnL>
+                    <a:lnR w="9525" cap="flat" cmpd="sng" algn="ctr">
+                      <a:solidFill>
+                        <a:srgbClr val="C9D3E0"/>
+                      </a:solidFill>
+                      <a:prstDash val="solid"/>
+                      <a:round/>
+                      <a:headEnd type="none" w="med" len="med"/>
+                      <a:tailEnd type="none" w="med" len="med"/>
+                    </a:lnR>
+                    <a:lnT w="9525" cap="flat" cmpd="sng" algn="ctr">
+                      <a:solidFill>
+                        <a:srgbClr val="C9D3E0"/>
+                      </a:solidFill>
+                      <a:prstDash val="solid"/>
+                      <a:round/>
+                      <a:headEnd type="none" w="med" len="med"/>
+                      <a:tailEnd type="none" w="med" len="med"/>
+                    </a:lnT>
+                    <a:lnB w="9525" cap="flat" cmpd="sng" algn="ctr">
+                      <a:solidFill>
+                        <a:srgbClr val="C9D3E0"/>
+                      </a:solidFill>
+                      <a:prstDash val="solid"/>
+                      <a:round/>
+                      <a:headEnd type="none" w="med" len="med"/>
+                      <a:tailEnd type="none" w="med" len="med"/>
+                    </a:lnB>
+                    <a:solidFill>
+                      <a:srgbClr val="FFFFFF"/>
+                    </a:solidFill>
+                  </a:tcPr>
+                </a:tc>
+                <a:tc>
+                  <a:txBody>
+                    <a:bodyPr/>
+                    <a:lstStyle/>
+                    <a:p>
+                      <a:pPr algn="ctr" indent="0" marL="0">
+                        <a:buNone/>
+                      </a:pPr>
                       <a:endParaRPr lang="en-US" sz="1200" dirty="0">
                         <a:latin typeface="Calibri" charset="0"/>
                         <a:ea typeface="Calibri" charset="0"/>
@@ -9233,6 +9244,17 @@
                       <a:pPr algn="ctr" indent="0" marL="0">
                         <a:buNone/>
                       </a:pPr>
+                      <a:r>
+                        <a:rPr lang="en-US" sz="1200" dirty="0">
+                          <a:solidFill>
+                            <a:srgbClr val="1E2430"/>
+                          </a:solidFill>
+                          <a:latin typeface="Calibri" pitchFamily="34" charset="0"/>
+                          <a:ea typeface="Calibri" pitchFamily="34" charset="-122"/>
+                          <a:cs typeface="Calibri" pitchFamily="34" charset="-120"/>
+                        </a:rPr>
+                        <a:t>◐</a:t>
+                      </a:r>
                       <a:endParaRPr lang="en-US" sz="1200" dirty="0">
                         <a:latin typeface="Calibri" charset="0"/>
                         <a:ea typeface="Calibri" charset="0"/>
@@ -9358,6 +9380,17 @@
                       <a:pPr algn="ctr" indent="0" marL="0">
                         <a:buNone/>
                       </a:pPr>
+                      <a:r>
+                        <a:rPr lang="en-US" sz="1200" dirty="0">
+                          <a:solidFill>
+                            <a:srgbClr val="1E2430"/>
+                          </a:solidFill>
+                          <a:latin typeface="Calibri" pitchFamily="34" charset="0"/>
+                          <a:ea typeface="Calibri" pitchFamily="34" charset="-122"/>
+                          <a:cs typeface="Calibri" pitchFamily="34" charset="-120"/>
+                        </a:rPr>
+                        <a:t>◐</a:t>
+                      </a:r>
                       <a:endParaRPr lang="en-US" sz="1200" dirty="0">
                         <a:latin typeface="Calibri" charset="0"/>
                         <a:ea typeface="Calibri" charset="0"/>
@@ -9610,17 +9643,63 @@
                       <a:pPr algn="ctr" indent="0" marL="0">
                         <a:buNone/>
                       </a:pPr>
-                      <a:r>
-                        <a:rPr lang="en-US" sz="1200" dirty="0">
-                          <a:solidFill>
-                            <a:srgbClr val="1E2430"/>
-                          </a:solidFill>
-                          <a:latin typeface="Calibri" pitchFamily="34" charset="0"/>
-                          <a:ea typeface="Calibri" pitchFamily="34" charset="-122"/>
-                          <a:cs typeface="Calibri" pitchFamily="34" charset="-120"/>
-                        </a:rPr>
-                        <a:t>●</a:t>
-                      </a:r>
+                      <a:endParaRPr lang="en-US" sz="1200" dirty="0">
+                        <a:latin typeface="Calibri" charset="0"/>
+                        <a:ea typeface="Calibri" charset="0"/>
+                        <a:cs typeface="Calibri" charset="0"/>
+                      </a:endParaRPr>
+                    </a:p>
+                  </a:txBody>
+                  <a:tcPr marL="36576" marR="36576" marT="36576" marB="36576" anchor="ctr">
+                    <a:lnL w="9525" cap="flat" cmpd="sng" algn="ctr">
+                      <a:solidFill>
+                        <a:srgbClr val="C9D3E0"/>
+                      </a:solidFill>
+                      <a:prstDash val="solid"/>
+                      <a:round/>
+                      <a:headEnd type="none" w="med" len="med"/>
+                      <a:tailEnd type="none" w="med" len="med"/>
+                    </a:lnL>
+                    <a:lnR w="9525" cap="flat" cmpd="sng" algn="ctr">
+                      <a:solidFill>
+                        <a:srgbClr val="C9D3E0"/>
+                      </a:solidFill>
+                      <a:prstDash val="solid"/>
+                      <a:round/>
+                      <a:headEnd type="none" w="med" len="med"/>
+                      <a:tailEnd type="none" w="med" len="med"/>
+                    </a:lnR>
+                    <a:lnT w="9525" cap="flat" cmpd="sng" algn="ctr">
+                      <a:solidFill>
+                        <a:srgbClr val="C9D3E0"/>
+                      </a:solidFill>
+                      <a:prstDash val="solid"/>
+                      <a:round/>
+                      <a:headEnd type="none" w="med" len="med"/>
+                      <a:tailEnd type="none" w="med" len="med"/>
+                    </a:lnT>
+                    <a:lnB w="9525" cap="flat" cmpd="sng" algn="ctr">
+                      <a:solidFill>
+                        <a:srgbClr val="C9D3E0"/>
+                      </a:solidFill>
+                      <a:prstDash val="solid"/>
+                      <a:round/>
+                      <a:headEnd type="none" w="med" len="med"/>
+                      <a:tailEnd type="none" w="med" len="med"/>
+                    </a:lnB>
+                    <a:solidFill>
+                      <a:srgbClr val="FFFFFF"/>
+                    </a:solidFill>
+                  </a:tcPr>
+                </a:tc>
+                <a:tc>
+                  <a:txBody>
+                    <a:bodyPr/>
+                    <a:lstStyle/>
+                    <a:p>
+                      <a:pPr algn="ctr" indent="0" marL="0">
+                        <a:buNone/>
+                      </a:pPr>
                       <a:endParaRPr lang="en-US" sz="1200" dirty="0">
                         <a:latin typeface="Calibri" charset="0"/>
                         <a:ea typeface="Calibri" charset="0"/>
@@ -9687,65 +9766,8 @@
                           <a:ea typeface="Calibri" pitchFamily="34" charset="-122"/>
                           <a:cs typeface="Calibri" pitchFamily="34" charset="-120"/>
                         </a:rPr>
-                        <a:t>●</a:t>
+                        <a:t>◐</a:t>
                       </a:r>
-                      <a:endParaRPr lang="en-US" sz="1200" dirty="0">
-                        <a:latin typeface="Calibri" charset="0"/>
-                        <a:ea typeface="Calibri" charset="0"/>
-                        <a:cs typeface="Calibri" charset="0"/>
-                      </a:endParaRPr>
-                    </a:p>
-                  </a:txBody>
-                  <a:tcPr marL="36576" marR="36576" marT="36576" marB="36576" anchor="ctr">
-                    <a:lnL w="9525" cap="flat" cmpd="sng" algn="ctr">
-                      <a:solidFill>
-                        <a:srgbClr val="C9D3E0"/>
-                      </a:solidFill>
-                      <a:prstDash val="solid"/>
-                      <a:round/>
-                      <a:headEnd type="none" w="med" len="med"/>
-                      <a:tailEnd type="none" w="med" len="med"/>
-                    </a:lnL>
-                    <a:lnR w="9525" cap="flat" cmpd="sng" algn="ctr">
-                      <a:solidFill>
-                        <a:srgbClr val="C9D3E0"/>
-                      </a:solidFill>
-                      <a:prstDash val="solid"/>
-                      <a:round/>
-                      <a:headEnd type="none" w="med" len="med"/>
-                      <a:tailEnd type="none" w="med" len="med"/>
-                    </a:lnR>
-                    <a:lnT w="9525" cap="flat" cmpd="sng" algn="ctr">
-                      <a:solidFill>
-                        <a:srgbClr val="C9D3E0"/>
-                      </a:solidFill>
-                      <a:prstDash val="solid"/>
-                      <a:round/>
-                      <a:headEnd type="none" w="med" len="med"/>
-                      <a:tailEnd type="none" w="med" len="med"/>
-                    </a:lnT>
-                    <a:lnB w="9525" cap="flat" cmpd="sng" algn="ctr">
-                      <a:solidFill>
-                        <a:srgbClr val="C9D3E0"/>
-                      </a:solidFill>
-                      <a:prstDash val="solid"/>
-                      <a:round/>
-                      <a:headEnd type="none" w="med" len="med"/>
-                      <a:tailEnd type="none" w="med" len="med"/>
-                    </a:lnB>
-                    <a:solidFill>
-                      <a:srgbClr val="FFFFFF"/>
-                    </a:solidFill>
-                  </a:tcPr>
-                </a:tc>
-                <a:tc>
-                  <a:txBody>
-                    <a:bodyPr/>
-                    <a:lstStyle/>
-                    <a:p>
-                      <a:pPr algn="ctr" indent="0" marL="0">
-                        <a:buNone/>
-                      </a:pPr>
                       <a:endParaRPr lang="en-US" sz="1200" dirty="0">
                         <a:latin typeface="Calibri" charset="0"/>
                         <a:ea typeface="Calibri" charset="0"/>
@@ -9998,85 +10020,6 @@
                       <a:pPr algn="ctr" indent="0" marL="0">
                         <a:buNone/>
                       </a:pPr>
-                      <a:r>
-                        <a:rPr lang="en-US" sz="1200" dirty="0">
-                          <a:solidFill>
-                            <a:srgbClr val="1E2430"/>
-                          </a:solidFill>
-                          <a:latin typeface="Calibri" pitchFamily="34" charset="0"/>
-                          <a:ea typeface="Calibri" pitchFamily="34" charset="-122"/>
-                          <a:cs typeface="Calibri" pitchFamily="34" charset="-120"/>
-                        </a:rPr>
-                        <a:t>◐</a:t>
-                      </a:r>
-                      <a:endParaRPr lang="en-US" sz="1200" dirty="0">
-                        <a:latin typeface="Calibri" charset="0"/>
-                        <a:ea typeface="Calibri" charset="0"/>
-                        <a:cs typeface="Calibri" charset="0"/>
-                      </a:endParaRPr>
-                    </a:p>
-                  </a:txBody>
-                  <a:tcPr marL="36576" marR="36576" marT="36576" marB="36576" anchor="ctr">
-                    <a:lnL w="9525" cap="flat" cmpd="sng" algn="ctr">
-                      <a:solidFill>
-                        <a:srgbClr val="C9D3E0"/>
-                      </a:solidFill>
-                      <a:prstDash val="solid"/>
-                      <a:round/>
-                      <a:headEnd type="none" w="med" len="med"/>
-                      <a:tailEnd type="none" w="med" len="med"/>
-                    </a:lnL>
-                    <a:lnR w="9525" cap="flat" cmpd="sng" algn="ctr">
-                      <a:solidFill>
-                        <a:srgbClr val="C9D3E0"/>
-                      </a:solidFill>
-                      <a:prstDash val="solid"/>
-                      <a:round/>
-                      <a:headEnd type="none" w="med" len="med"/>
-                      <a:tailEnd type="none" w="med" len="med"/>
-                    </a:lnR>
-                    <a:lnT w="9525" cap="flat" cmpd="sng" algn="ctr">
-                      <a:solidFill>
-                        <a:srgbClr val="C9D3E0"/>
-                      </a:solidFill>
-                      <a:prstDash val="solid"/>
-                      <a:round/>
-                      <a:headEnd type="none" w="med" len="med"/>
-                      <a:tailEnd type="none" w="med" len="med"/>
-                    </a:lnT>
-                    <a:lnB w="9525" cap="flat" cmpd="sng" algn="ctr">
-                      <a:solidFill>
-                        <a:srgbClr val="C9D3E0"/>
-                      </a:solidFill>
-                      <a:prstDash val="solid"/>
-                      <a:round/>
-                      <a:headEnd type="none" w="med" len="med"/>
-                      <a:tailEnd type="none" w="med" len="med"/>
-                    </a:lnB>
-                    <a:solidFill>
-                      <a:srgbClr val="FFFFFF"/>
-                    </a:solidFill>
-                  </a:tcPr>
-                </a:tc>
-                <a:tc>
-                  <a:txBody>
-                    <a:bodyPr/>
-                    <a:lstStyle/>
-                    <a:p>
-                      <a:pPr algn="ctr" indent="0" marL="0">
-                        <a:buNone/>
-                      </a:pPr>
-                      <a:r>
-                        <a:rPr lang="en-US" sz="1200" dirty="0">
-                          <a:solidFill>
-                            <a:srgbClr val="1E2430"/>
-                          </a:solidFill>
-                          <a:latin typeface="Calibri" pitchFamily="34" charset="0"/>
-                          <a:ea typeface="Calibri" pitchFamily="34" charset="-122"/>
-                          <a:cs typeface="Calibri" pitchFamily="34" charset="-120"/>
-                        </a:rPr>
-                        <a:t>●</a:t>
-                      </a:r>
                       <a:endParaRPr lang="en-US" sz="1200" dirty="0">
                         <a:latin typeface="Calibri" charset="0"/>
                         <a:ea typeface="Calibri" charset="0"/>
@@ -10202,6 +10145,63 @@
                         </a:rPr>
                         <a:t>◐</a:t>
                       </a:r>
+                      <a:endParaRPr lang="en-US" sz="1200" dirty="0">
+                        <a:latin typeface="Calibri" charset="0"/>
+                        <a:ea typeface="Calibri" charset="0"/>
+                        <a:cs typeface="Calibri" charset="0"/>
+                      </a:endParaRPr>
+                    </a:p>
+                  </a:txBody>
+                  <a:tcPr marL="36576" marR="36576" marT="36576" marB="36576" anchor="ctr">
+                    <a:lnL w="9525" cap="flat" cmpd="sng" algn="ctr">
+                      <a:solidFill>
+                        <a:srgbClr val="C9D3E0"/>
+                      </a:solidFill>
+                      <a:prstDash val="solid"/>
+                      <a:round/>
+                      <a:headEnd type="none" w="med" len="med"/>
+                      <a:tailEnd type="none" w="med" len="med"/>
+                    </a:lnL>
+                    <a:lnR w="9525" cap="flat" cmpd="sng" algn="ctr">
+                      <a:solidFill>
+                        <a:srgbClr val="C9D3E0"/>
+                      </a:solidFill>
+                      <a:prstDash val="solid"/>
+                      <a:round/>
+                      <a:headEnd type="none" w="med" len="med"/>
+                      <a:tailEnd type="none" w="med" len="med"/>
+                    </a:lnR>
+                    <a:lnT w="9525" cap="flat" cmpd="sng" algn="ctr">
+                      <a:solidFill>
+                        <a:srgbClr val="C9D3E0"/>
+                      </a:solidFill>
+                      <a:prstDash val="solid"/>
+                      <a:round/>
+                      <a:headEnd type="none" w="med" len="med"/>
+                      <a:tailEnd type="none" w="med" len="med"/>
+                    </a:lnT>
+                    <a:lnB w="9525" cap="flat" cmpd="sng" algn="ctr">
+                      <a:solidFill>
+                        <a:srgbClr val="C9D3E0"/>
+                      </a:solidFill>
+                      <a:prstDash val="solid"/>
+                      <a:round/>
+                      <a:headEnd type="none" w="med" len="med"/>
+                      <a:tailEnd type="none" w="med" len="med"/>
+                    </a:lnB>
+                    <a:solidFill>
+                      <a:srgbClr val="FFFFFF"/>
+                    </a:solidFill>
+                  </a:tcPr>
+                </a:tc>
+                <a:tc>
+                  <a:txBody>
+                    <a:bodyPr/>
+                    <a:lstStyle/>
+                    <a:p>
+                      <a:pPr algn="ctr" indent="0" marL="0">
+                        <a:buNone/>
+                      </a:pPr>
                       <a:endParaRPr lang="en-US" sz="1200" dirty="0">
                         <a:latin typeface="Calibri" charset="0"/>
                         <a:ea typeface="Calibri" charset="0"/>
@@ -10397,17 +10397,6 @@
                       <a:pPr algn="ctr" indent="0" marL="0">
                         <a:buNone/>
                       </a:pPr>
-                      <a:r>
-                        <a:rPr lang="en-US" sz="1200" dirty="0">
-                          <a:solidFill>
-                            <a:srgbClr val="1E2430"/>
-                          </a:solidFill>
-                          <a:latin typeface="Calibri" pitchFamily="34" charset="0"/>
-                          <a:ea typeface="Calibri" pitchFamily="34" charset="-122"/>
-                          <a:cs typeface="Calibri" pitchFamily="34" charset="-120"/>
-                        </a:rPr>
-                        <a:t>●</a:t>
-                      </a:r>
                       <a:endParaRPr lang="en-US" sz="1200" dirty="0">
                         <a:latin typeface="Calibri" charset="0"/>
                         <a:ea typeface="Calibri" charset="0"/>
@@ -10465,6 +10454,17 @@
                       <a:pPr algn="ctr" indent="0" marL="0">
                         <a:buNone/>
                       </a:pPr>
+                      <a:r>
+                        <a:rPr lang="en-US" sz="1200" dirty="0">
+                          <a:solidFill>
+                            <a:srgbClr val="1E2430"/>
+                          </a:solidFill>
+                          <a:latin typeface="Calibri" pitchFamily="34" charset="0"/>
+                          <a:ea typeface="Calibri" pitchFamily="34" charset="-122"/>
+                          <a:cs typeface="Calibri" pitchFamily="34" charset="-120"/>
+                        </a:rPr>
+                        <a:t>◐</a:t>
+                      </a:r>
                       <a:endParaRPr lang="en-US" sz="1200" dirty="0">
                         <a:latin typeface="Calibri" charset="0"/>
                         <a:ea typeface="Calibri" charset="0"/>
@@ -10522,6 +10522,17 @@
                       <a:pPr algn="ctr" indent="0" marL="0">
                         <a:buNone/>
                       </a:pPr>
+                      <a:r>
+                        <a:rPr lang="en-US" sz="1200" dirty="0">
+                          <a:solidFill>
+                            <a:srgbClr val="1E2430"/>
+                          </a:solidFill>
+                          <a:latin typeface="Calibri" pitchFamily="34" charset="0"/>
+                          <a:ea typeface="Calibri" pitchFamily="34" charset="-122"/>
+                          <a:cs typeface="Calibri" pitchFamily="34" charset="-120"/>
+                        </a:rPr>
+                        <a:t>◐</a:t>
+                      </a:r>
                       <a:endParaRPr lang="en-US" sz="1200" dirty="0">
                         <a:latin typeface="Calibri" charset="0"/>
                         <a:ea typeface="Calibri" charset="0"/>
@@ -10674,7 +10685,7 @@
                   <a:srgbClr val="5B6472"/>
                 </a:solidFill>
               </a:rPr>
-              <a:t>● has it   ◐ partial form.  From our 225-paper archive review (NOVELTY.md, section 5.3).</a:t>
+              <a:t>● has it   ◐ partial form. Full-text reads of the 37 closest papers (NOVELTY.md 5.8).</a:t>
             </a:r>
             <a:endParaRPr lang="en-US" sz="900" dirty="0"/>
           </a:p>
@@ -10746,7 +10757,7 @@
                   <a:schemeClr val="tx1"/>
                 </a:solidFill>
               </a:rPr>
-              <a:t>the detector is a 2016-style threshold chain; Indian labels come from one event; no user study yet; the 914 km² figure includes the river and wetlands.</a:t>
+              <a:t>the detector is a classic split-based threshold chain; Indian labels come from one event; no user study yet; the 914 km² figure includes the river and wetlands.</a:t>
             </a:r>
             <a:endParaRPr lang="en-US" sz="1100" dirty="0"/>
           </a:p>

</xml_diff>